<commit_message>
More fixes in slides
</commit_message>
<xml_diff>
--- a/clang-tools-extra/clangd/presentation_clangd_pseudoparser.pptx
+++ b/clang-tools-extra/clangd/presentation_clangd_pseudoparser.pptx
@@ -6674,7 +6674,7 @@
               </a:defRPr>
             </a:pPr>
             <a:r>
-              <a:t>Precise DeclKind Classification &amp; Include BFS</a:t>
+              <a:t>Precise DeclKind Declaration Classification</a:t>
             </a:r>
           </a:p>
           <a:p>
@@ -6715,7 +6715,7 @@
                   <a:srgbClr val="F8FAFC"/>
                 </a:solidFill>
               </a:rPr>
-              <a:t>Clang-Pseudo grammar maps directly to DeclKind (Class, Struct, Enum, Typedef, Namespace), powering bounded header BFS for instant cross-file Go-To-Definition.</a:t>
+              <a:t>Clang-Pseudo grammar maps directly to DeclKind (Class, Struct, Enum, Typedef, Namespace) — native typed classification directly from grammar rules.</a:t>
             </a:r>
           </a:p>
         </p:txBody>
@@ -6811,7 +6811,7 @@
               </a:defRPr>
             </a:pPr>
             <a:r>
-              <a:t>AI AGENT &amp; RAG ADVANTAGE</a:t>
+              <a:t>AI AGENT &amp; TOOLING COMPARISON</a:t>
             </a:r>
           </a:p>
         </p:txBody>
@@ -6939,8 +6939,8 @@
         </p:nvSpPr>
         <p:spPr>
           <a:xfrm>
-            <a:off x="914400" y="1554480"/>
-            <a:ext cx="4892040" cy="1965960"/>
+            <a:off x="914400" y="1508760"/>
+            <a:ext cx="4892040" cy="2057400"/>
           </a:xfrm>
           <a:prstGeom prst="rect">
             <a:avLst/>
@@ -6955,26 +6955,57 @@
           <a:p>
             <a:pPr>
               <a:spcAft>
-                <a:spcPts val="800"/>
-              </a:spcAft>
-              <a:defRPr sz="1400" b="1">
+                <a:spcPts val="600"/>
+              </a:spcAft>
+              <a:defRPr sz="1300" b="1">
                 <a:solidFill>
                   <a:srgbClr val="38BDF8"/>
                 </a:solidFill>
               </a:defRPr>
             </a:pPr>
             <a:r>
-              <a:t>1. Formally Correct Syntax Gating</a:t>
-            </a:r>
-          </a:p>
-          <a:p>
-            <a:r>
-              <a:rPr sz="1150">
+              <a:t>Streaming Syntax Gating (Validation)</a:t>
+            </a:r>
+          </a:p>
+          <a:p>
+            <a:pPr>
+              <a:spcAft>
+                <a:spcPts val="400"/>
+              </a:spcAft>
+            </a:pPr>
+            <a:r>
+              <a:rPr b="1" sz="1100">
+                <a:solidFill>
+                  <a:srgbClr val="F87171"/>
+                </a:solidFill>
+              </a:rPr>
+              <a:t>Tree-sitter: </a:t>
+            </a:r>
+            <a:r>
+              <a:rPr sz="1100">
                 <a:solidFill>
                   <a:srgbClr val="94A3B8"/>
                 </a:solidFill>
               </a:rPr>
-              <a:t>For streaming LLM code generation and speculative decoding. Tree-sitter's approximate grammar silently accepts invalid C++ or rejects advanced valid C++ (concepts, requires clauses). Clang-Pseudo provides strict ISO syntax validation in &lt;10ms without headers.</a:t>
+              <a:t>Handcrafted approximate grammar (grammar.js) silently accepts malformed C++ or falsely rejects valid C++20 constructs.</a:t>
+            </a:r>
+          </a:p>
+          <a:p>
+            <a:r>
+              <a:rPr b="1" sz="1100">
+                <a:solidFill>
+                  <a:srgbClr val="34D399"/>
+                </a:solidFill>
+              </a:rPr>
+              <a:t>Clang-Pseudo: </a:t>
+            </a:r>
+            <a:r>
+              <a:rPr sz="1100">
+                <a:solidFill>
+                  <a:srgbClr val="F8FAFC"/>
+                </a:solidFill>
+              </a:rPr>
+              <a:t>Strict ISO standard BNF (N4860) validates syntax with 100% formal language fidelity — zero false rejections during constrained decoding.</a:t>
             </a:r>
           </a:p>
         </p:txBody>
@@ -7032,8 +7063,8 @@
         </p:nvSpPr>
         <p:spPr>
           <a:xfrm>
-            <a:off x="6355080" y="1554480"/>
-            <a:ext cx="4892040" cy="1965960"/>
+            <a:off x="6355080" y="1508760"/>
+            <a:ext cx="4892040" cy="2057400"/>
           </a:xfrm>
           <a:prstGeom prst="rect">
             <a:avLst/>
@@ -7048,26 +7079,57 @@
           <a:p>
             <a:pPr>
               <a:spcAft>
-                <a:spcPts val="800"/>
-              </a:spcAft>
-              <a:defRPr sz="1400" b="1">
+                <a:spcPts val="600"/>
+              </a:spcAft>
+              <a:defRPr sz="1300" b="1">
                 <a:solidFill>
                   <a:srgbClr val="34D399"/>
                 </a:solidFill>
               </a:defRPr>
             </a:pPr>
             <a:r>
-              <a:t>2. High-Density AST Skeletonization for RAG</a:t>
-            </a:r>
-          </a:p>
-          <a:p>
-            <a:r>
-              <a:rPr sz="1150">
+              <a:t>Lossless AST Skeletonization (RAG)</a:t>
+            </a:r>
+          </a:p>
+          <a:p>
+            <a:pPr>
+              <a:spcAft>
+                <a:spcPts val="400"/>
+              </a:spcAft>
+            </a:pPr>
+            <a:r>
+              <a:rPr b="1" sz="1100">
+                <a:solidFill>
+                  <a:srgbClr val="F87171"/>
+                </a:solidFill>
+              </a:rPr>
+              <a:t>Tree-sitter: </a:t>
+            </a:r>
+            <a:r>
+              <a:rPr sz="1100">
                 <a:solidFill>
                   <a:srgbClr val="94A3B8"/>
                 </a:solidFill>
               </a:rPr>
-              <a:t>LLM context windows are expensive. Clang-Pseudo extracts exact class, template, and function signatures in 50ms while stripping function bodies — packing 10x more repository interface context into prompts with zero compiler setup.</a:t>
+              <a:t>Simplified grammar misparses templates and concepts; fragile S-expression queries break and drop nested type signatures.</a:t>
+            </a:r>
+          </a:p>
+          <a:p>
+            <a:r>
+              <a:rPr b="1" sz="1100">
+                <a:solidFill>
+                  <a:srgbClr val="34D399"/>
+                </a:solidFill>
+              </a:rPr>
+              <a:t>Clang-Pseudo: </a:t>
+            </a:r>
+            <a:r>
+              <a:rPr sz="1100">
+                <a:solidFill>
+                  <a:srgbClr val="F8FAFC"/>
+                </a:solidFill>
+              </a:rPr>
+              <a:t>Lossless signature extraction strips function bodies while preserving complete ISO types, concepts, and member scopes for prompts.</a:t>
             </a:r>
           </a:p>
         </p:txBody>
@@ -7125,8 +7187,8 @@
         </p:nvSpPr>
         <p:spPr>
           <a:xfrm>
-            <a:off x="914400" y="4069080"/>
-            <a:ext cx="4892040" cy="1965960"/>
+            <a:off x="914400" y="4023360"/>
+            <a:ext cx="4892040" cy="2057400"/>
           </a:xfrm>
           <a:prstGeom prst="rect">
             <a:avLst/>
@@ -7141,26 +7203,57 @@
           <a:p>
             <a:pPr>
               <a:spcAft>
-                <a:spcPts val="800"/>
-              </a:spcAft>
-              <a:defRPr sz="1400" b="1">
+                <a:spcPts val="600"/>
+              </a:spcAft>
+              <a:defRPr sz="1300" b="1">
                 <a:solidFill>
                   <a:srgbClr val="FBBF24"/>
                 </a:solidFill>
               </a:defRPr>
             </a:pPr>
             <a:r>
-              <a:t>3. 70x Faster Feedback Loops for Coding Agents</a:t>
-            </a:r>
-          </a:p>
-          <a:p>
-            <a:r>
-              <a:rPr sz="1150">
+              <a:t>Symbol &amp; Scope Classification (DeclKind)</a:t>
+            </a:r>
+          </a:p>
+          <a:p>
+            <a:pPr>
+              <a:spcAft>
+                <a:spcPts val="400"/>
+              </a:spcAft>
+            </a:pPr>
+            <a:r>
+              <a:rPr b="1" sz="1100">
+                <a:solidFill>
+                  <a:srgbClr val="F87171"/>
+                </a:solidFill>
+              </a:rPr>
+              <a:t>Tree-sitter: </a:t>
+            </a:r>
+            <a:r>
+              <a:rPr sz="1100">
                 <a:solidFill>
                   <a:srgbClr val="94A3B8"/>
                 </a:solidFill>
               </a:rPr>
-              <a:t>Autonomous coding agents (Cursor, Claude Code, Antigravity) make multi-step code edits. Waiting 3.6–10s per edit for AST rebuild stalls agent execution. Clang-Pseudo validates modified scopes in 50ms instead of 3,600ms.</a:t>
+              <a:t>Emits coarse, ambiguous node types (type_identifier); cannot reliably classify classes, concepts, or typedefs without fragile ad-hoc queries.</a:t>
+            </a:r>
+          </a:p>
+          <a:p>
+            <a:r>
+              <a:rPr b="1" sz="1100">
+                <a:solidFill>
+                  <a:srgbClr val="34D399"/>
+                </a:solidFill>
+              </a:rPr>
+              <a:t>Clang-Pseudo: </a:t>
+            </a:r>
+            <a:r>
+              <a:rPr sz="1100">
+                <a:solidFill>
+                  <a:srgbClr val="F8FAFC"/>
+                </a:solidFill>
+              </a:rPr>
+              <a:t>Maps AST nodes directly to formal DeclKind (Class, Struct, Enum, Concept, Namespace) — exact syntactic taxonomy for AI tools.</a:t>
             </a:r>
           </a:p>
         </p:txBody>
@@ -7218,8 +7311,8 @@
         </p:nvSpPr>
         <p:spPr>
           <a:xfrm>
-            <a:off x="6355080" y="4069080"/>
-            <a:ext cx="4892040" cy="1965960"/>
+            <a:off x="6355080" y="4023360"/>
+            <a:ext cx="4892040" cy="2057400"/>
           </a:xfrm>
           <a:prstGeom prst="rect">
             <a:avLst/>
@@ -7234,26 +7327,57 @@
           <a:p>
             <a:pPr>
               <a:spcAft>
-                <a:spcPts val="800"/>
-              </a:spcAft>
-              <a:defRPr sz="1400" b="1">
+                <a:spcPts val="600"/>
+              </a:spcAft>
+              <a:defRPr sz="1300" b="1">
                 <a:solidFill>
                   <a:srgbClr val="C084FC"/>
                 </a:solidFill>
               </a:defRPr>
             </a:pPr>
             <a:r>
-              <a:t>4. Clean Monorepo Indexing at Scale</a:t>
-            </a:r>
-          </a:p>
-          <a:p>
-            <a:r>
-              <a:rPr sz="1150">
+              <a:t>Monorepo Vector Indexing Resilience</a:t>
+            </a:r>
+          </a:p>
+          <a:p>
+            <a:pPr>
+              <a:spcAft>
+                <a:spcPts val="400"/>
+              </a:spcAft>
+            </a:pPr>
+            <a:r>
+              <a:rPr b="1" sz="1100">
+                <a:solidFill>
+                  <a:srgbClr val="F87171"/>
+                </a:solidFill>
+              </a:rPr>
+              <a:t>Tree-sitter: </a:t>
+            </a:r>
+            <a:r>
+              <a:rPr sz="1100">
                 <a:solidFill>
                   <a:srgbClr val="94A3B8"/>
                 </a:solidFill>
               </a:rPr>
-              <a:t>Codebases like Chromium or Linux kernel break Tree-sitter with (ERROR) nodes on ~20% of files due to complex #ifdefs. DirectiveTree yields clean, complete parse trees across millions of files, generating reliable semantic chunks for vector search.</a:t>
+              <a:t>Inlines #ifdefs as syntax nodes; competing branch brackets trigger cascaded (ERROR) nodes across ~20% of files, mangling chunks.</a:t>
+            </a:r>
+          </a:p>
+          <a:p>
+            <a:r>
+              <a:rPr b="1" sz="1100">
+                <a:solidFill>
+                  <a:srgbClr val="34D399"/>
+                </a:solidFill>
+              </a:rPr>
+              <a:t>Clang-Pseudo: </a:t>
+            </a:r>
+            <a:r>
+              <a:rPr sz="1100">
+                <a:solidFill>
+                  <a:srgbClr val="F8FAFC"/>
+                </a:solidFill>
+              </a:rPr>
+              <a:t>DirectiveTree branch pruning resolves conditional branches cleanly before GLR parsing — pristine chunk boundaries for embeddings.</a:t>
             </a:r>
           </a:p>
         </p:txBody>

</xml_diff>